<commit_message>
Correct MBB figures after fact check
Fact-checked every number against Vietnamese financial press. Four fixes:

- Total assets 2025 were 1.615.764 tỷ (+43%), not ~1,5 triệu tỷ (+33%). The
  lower number was MB's early-January estimate, still circulating in
  secondary coverage. Chart on slide 3 and speaker notes corrected.
- Slide 6 anchored asset growth to Q1/2026; assets in fact slipped 0,3% that
  quarter. Re-anchored to the end-2025 balance sheet.
- ROE stated as 21,6%; MB's own 2025 disclosure is 21,1%.
- Target-price range omitted VCBS at 37.230, the high end. Now 32.900-37.230.

README gains a per-figure verification status and records three caveats:
the equity series is a broker projection, CASA leadership is a narrow lead
Techcombank held at 9M2025, and Q1/2026 saw deposit outflows the deck
does not show.

Co-Authored-By: Claude Opus 5 <noreply@anthropic.com>
Claude-Session: https://claude.ai/code/session_01W4wnn8T5rpb6YmEh93LGX5
</commit_message>
<xml_diff>
--- a/hotstock-mbb/Ngan_hang_MBB_Hotstock.pptx
+++ b/hotstock-mbb/Ngan_hang_MBB_Hotstock.pptx
@@ -348,7 +348,7 @@
                   <c:v>1133797</c:v>
                 </c:pt>
                 <c:pt idx="3">
-                  <c:v>1500000</c:v>
+                  <c:v>1615764</c:v>
                 </c:pt>
                 <c:pt idx="4">
                   <c:v>2100000</c:v>
@@ -2787,7 +2787,7 @@
           <a:p>
             <a:r>
               <a:rPr lang="en-US"/>
-              <a:t>Tổng tài sản tăng từ 728.532 tỷ (2022) lên gần 1,5 triệu tỷ (2025), mục tiêu vượt 2,1 triệu tỷ năm 2026. Vốn điều lệ lên tối đa 102.687 tỷ.</a:t>
+              <a:t>Tổng tài sản tăng từ 728.532 tỷ (2022) lên 1.615.764 tỷ cuối 2025, tăng 43%. Mục tiêu vượt 2,1 triệu tỷ năm 2026, vốn điều lệ lên tối đa 102.687 tỷ.</a:t>
             </a:r>
           </a:p>
         </p:txBody>
@@ -2880,7 +2880,7 @@
           <a:p>
             <a:r>
               <a:rPr lang="en-US"/>
-              <a:t>CASA ~38% cuối 2025, cao nhất hệ thống, số dư tăng ~27%. Nhận chuyển giao MBV nên được giao room tín dụng nhóm cao nhất 2026-2028. ROE trên 21%.</a:t>
+              <a:t>CASA ~38% cuối 2025, dẫn đầu hệ thống. Nhận chuyển giao MBV nên được giao room tín dụng nhóm cao nhất 2026-2028, mục tiêu 30-35%. ROE 2025 đạt 21,1%.</a:t>
             </a:r>
           </a:p>
         </p:txBody>
@@ -3078,7 +3078,7 @@
           <a:p>
             <a:r>
               <a:rPr lang="en-US"/>
-              <a:t>Tổng tài sản vượt 1,6 triệu tỷ cuối quý I/2026, mục tiêu vượt 2,1 triệu tỷ. Vốn điều lệ lên tối đa 102.687 tỷ, cổ tức 25% gồm 10% tiền mặt và 15% cổ phiếu.</a:t>
+              <a:t>Tổng tài sản 1.615.764 tỷ cuối 2025, tăng 43%; mục tiêu vượt 2,1 triệu tỷ. Vốn điều lệ lên tối đa 102.687 tỷ, cổ tức 25% gồm 10% tiền mặt và 15% cổ phiếu.</a:t>
             </a:r>
           </a:p>
         </p:txBody>
@@ -6929,7 +6929,7 @@
                 <a:ea typeface="Lora" pitchFamily="34" charset="-122"/>
                 <a:cs typeface="Lora" pitchFamily="34" charset="-120"/>
               </a:rPr>
-              <a:t>21,6%</a:t>
+              <a:t>21,1%</a:t>
             </a:r>
             <a:endParaRPr lang="en-US" sz="4650" dirty="0"/>
           </a:p>
@@ -7014,7 +7014,7 @@
                 <a:ea typeface="Calibri" pitchFamily="34" charset="-122"/>
                 <a:cs typeface="Calibri" pitchFamily="34" charset="-120"/>
               </a:rPr>
-              <a:t>ROE thuộc nhóm cao nhất trong các ngân hàng lớn</a:t>
+              <a:t>ROE 2025 thuộc nhóm cao nhất khối ngân hàng lớn</a:t>
             </a:r>
             <a:endParaRPr lang="en-US" sz="1800" dirty="0"/>
           </a:p>
@@ -7628,7 +7628,7 @@
                 <a:ea typeface="Calibri" pitchFamily="34" charset="-122"/>
                 <a:cs typeface="Calibri" pitchFamily="34" charset="-120"/>
               </a:rPr>
-              <a:t>MBB đặt mục tiêu tổng tài sản vượt 2,1 triệu tỷ đồng và nâng vốn điều lệ lên hơn 102.000 tỷ đồng ngay trong năm 2026.</a:t>
+              <a:t>Sau khi tổng tài sản tăng 43% trong năm 2025, MBB đặt mục tiêu vượt 2,1 triệu tỷ đồng và nâng vốn điều lệ lên hơn 102.000 tỷ đồng năm 2026.</a:t>
             </a:r>
             <a:endParaRPr lang="en-US" sz="1800" dirty="0"/>
           </a:p>
@@ -7917,7 +7917,7 @@
                 <a:ea typeface="Calibri" pitchFamily="34" charset="-122"/>
                 <a:cs typeface="Calibri" pitchFamily="34" charset="-120"/>
               </a:rPr>
-              <a:t>Tổng tài sản đã vượt 1,6 triệu tỷ đồng cuối quý I/2026, mục tiêu vượt 2,1 triệu tỷ trong năm.</a:t>
+              <a:t>Tổng tài sản đạt 1.615.764 tỷ đồng cuối 2025, tăng 43%; mục tiêu vượt 2,1 triệu tỷ năm 2026.</a:t>
             </a:r>
             <a:endParaRPr lang="en-US" sz="1875" dirty="0"/>
           </a:p>
@@ -7958,7 +7958,7 @@
                 <a:ea typeface="Calibri" pitchFamily="34" charset="-122"/>
                 <a:cs typeface="Calibri" pitchFamily="34" charset="-120"/>
               </a:rPr>
-              <a:t>Tín dụng tăng trưởng quanh mức 30%</a:t>
+              <a:t>Tín dụng mục tiêu tăng 30–35% năm 2026</a:t>
             </a:r>
             <a:endParaRPr lang="en-US" sz="1800" dirty="0"/>
           </a:p>

</xml_diff>